<commit_message>
Compress implementation roadmap to about one month
Client report page 7 now shows the six milestones across weeks 1–4,
then monthly care, with outcomes under each milestone name. Internal
roadmap, scope matrix, start-here map and private notes aligned.

Co-Authored-By: Claude Opus 5.5 <noreply@anthropic.com>
Claude-Session: https://claude.ai/code/session_01X11Xz3x2CWUNZZp7VgBa3D
</commit_message>
<xml_diff>
--- a/engagement/06-client-deck/MACK-Digital-Foundation.pptx
+++ b/engagement/06-client-deck/MACK-Digital-Foundation.pptx
@@ -115,34 +115,34 @@
   <p:extLst>
     <p:ext uri="{521415D9-36F7-43E2-AB2F-B90AF26B5E84}">
       <p14:sectionLst xmlns:p14="http://schemas.microsoft.com/office/powerpoint/2010/main">
-        <p14:section name="Opening" id="{4f08ddfd-8e78-8d23-6968-bb799af2bbac}">
+        <p14:section name="Opening" id="{a4cb95ce-9291-94c8-c5e7-65cc1a9b3206}">
           <p14:sldIdLst>
             <p14:sldId id="256"/>
           </p14:sldIdLst>
         </p14:section>
-        <p14:section name="System" id="{193b0a06-1b9f-02c7-ef85-14a1e1e144f0}">
+        <p14:section name="System" id="{8d2c5bd8-452f-921b-5e10-187a86ccbf46}">
           <p14:sldIdLst>
             <p14:sldId id="257"/>
             <p14:sldId id="258"/>
           </p14:sldIdLst>
         </p14:section>
-        <p14:section name="Foundation" id="{14fd3e46-3eb0-74e8-f999-a8bdae2e909f}">
+        <p14:section name="Foundation" id="{6d3a2281-a121-5aa2-8a42-2768d72865cf}">
           <p14:sldIdLst>
             <p14:sldId id="259"/>
           </p14:sldIdLst>
         </p14:section>
-        <p14:section name="Search" id="{7436b17e-8828-4051-8e41-359f719dc41d}">
+        <p14:section name="Search" id="{48e14ef5-b3e1-5ae3-c35d-3be6a4931575}">
           <p14:sldIdLst>
             <p14:sldId id="260"/>
             <p14:sldId id="261"/>
           </p14:sldIdLst>
         </p14:section>
-        <p14:section name="Roadmap" id="{642b92ba-8948-0dcb-cb49-235b15f5a88d}">
+        <p14:section name="Roadmap" id="{35261cc0-76fc-9dd7-543f-2608bda0f999}">
           <p14:sldIdLst>
             <p14:sldId id="262"/>
           </p14:sldIdLst>
         </p14:section>
-        <p14:section name="Close" id="{f2ea1f34-0ab5-91b1-559b-a4f573e75938}">
+        <p14:section name="Close" id="{49bc4aec-8f37-cf2e-323e-7610be406adb}">
           <p14:sldIdLst>
             <p14:sldId id="263"/>
             <p14:sldId id="264"/>
@@ -1080,7 +1080,7 @@
           <a:p>
             <a:r>
               <a:rPr lang="en-US" dirty="0"/>
-              <a:t>Foundation in the first two weeks; the site launched and connected to Google by week four; local presence from week three, depending on Google's verification; portfolio pages from week four, paced by project information from the studio; authority and digital growth from month three; measurement from week six, with a report every month after that.</a:t>
+              <a:t>Week one: domain, email, workspace and backup. The site launches and connects to Google in the first two weeks. Google Business Profile and portfolio pages run through weeks two to four; their exact timing follows Google's verification and the project information from the studio. Authority work and monthly measurement begin in week four and continue every month.</a:t>
             </a:r>
             <a:endParaRPr lang="en-US" dirty="0"/>
           </a:p>
@@ -9407,7 +9407,7 @@
                   <a:schemeClr val="tx1"/>
                 </a:solidFill>
               </a:rPr>
-              <a:t>Six milestones, about three months, then monthly</a:t>
+              <a:t>Six milestones in one month, then monthly care</a:t>
             </a:r>
             <a:endParaRPr lang="en-US" sz="3200" dirty="0"/>
           </a:p>
@@ -9422,7 +9422,7 @@
         <p:spPr>
           <a:xfrm>
             <a:off x="3429000" y="1691640"/>
-            <a:ext cx="2527402" cy="237744"/>
+            <a:ext cx="1642811" cy="237744"/>
           </a:xfrm>
           <a:prstGeom prst="rect">
             <a:avLst/>
@@ -9446,7 +9446,7 @@
                   <a:schemeClr val="accent2"/>
                 </a:solidFill>
               </a:rPr>
-              <a:t>Month 1</a:t>
+              <a:t>Week 1</a:t>
             </a:r>
             <a:endParaRPr lang="en-US" sz="1050" dirty="0"/>
           </a:p>
@@ -9483,8 +9483,8 @@
         </p:nvSpPr>
         <p:spPr>
           <a:xfrm>
-            <a:off x="5956402" y="1691640"/>
-            <a:ext cx="2527402" cy="237744"/>
+            <a:off x="5071811" y="1691640"/>
+            <a:ext cx="1642811" cy="237744"/>
           </a:xfrm>
           <a:prstGeom prst="rect">
             <a:avLst/>
@@ -9508,7 +9508,7 @@
                   <a:schemeClr val="accent2"/>
                 </a:solidFill>
               </a:rPr>
-              <a:t>Month 2</a:t>
+              <a:t>Week 2</a:t>
             </a:r>
             <a:endParaRPr lang="en-US" sz="1050" dirty="0"/>
           </a:p>
@@ -9522,7 +9522,7 @@
         </p:nvSpPr>
         <p:spPr>
           <a:xfrm>
-            <a:off x="5956402" y="2020824"/>
+            <a:off x="5071811" y="2020824"/>
             <a:ext cx="0" cy="3739896"/>
           </a:xfrm>
           <a:prstGeom prst="line">
@@ -9545,8 +9545,8 @@
         </p:nvSpPr>
         <p:spPr>
           <a:xfrm>
-            <a:off x="8483803" y="1691640"/>
-            <a:ext cx="2527402" cy="237744"/>
+            <a:off x="6714622" y="1691640"/>
+            <a:ext cx="1642811" cy="237744"/>
           </a:xfrm>
           <a:prstGeom prst="rect">
             <a:avLst/>
@@ -9570,7 +9570,7 @@
                   <a:schemeClr val="accent2"/>
                 </a:solidFill>
               </a:rPr>
-              <a:t>Month 3</a:t>
+              <a:t>Week 3</a:t>
             </a:r>
             <a:endParaRPr lang="en-US" sz="1050" dirty="0"/>
           </a:p>
@@ -9584,7 +9584,7 @@
         </p:nvSpPr>
         <p:spPr>
           <a:xfrm>
-            <a:off x="8483803" y="2020824"/>
+            <a:off x="6714622" y="2020824"/>
             <a:ext cx="0" cy="3739896"/>
           </a:xfrm>
           <a:prstGeom prst="line">
@@ -9607,8 +9607,8 @@
         </p:nvSpPr>
         <p:spPr>
           <a:xfrm>
-            <a:off x="11011205" y="1691640"/>
-            <a:ext cx="631850" cy="237744"/>
+            <a:off x="8357433" y="1691640"/>
+            <a:ext cx="1642811" cy="237744"/>
           </a:xfrm>
           <a:prstGeom prst="rect">
             <a:avLst/>
@@ -9632,7 +9632,7 @@
                   <a:schemeClr val="accent2"/>
                 </a:solidFill>
               </a:rPr>
-              <a:t>Ongoing</a:t>
+              <a:t>Week 4</a:t>
             </a:r>
             <a:endParaRPr lang="en-US" sz="1050" dirty="0"/>
           </a:p>
@@ -9646,7 +9646,7 @@
         </p:nvSpPr>
         <p:spPr>
           <a:xfrm>
-            <a:off x="11011205" y="2020824"/>
+            <a:off x="8357433" y="2020824"/>
             <a:ext cx="0" cy="3739896"/>
           </a:xfrm>
           <a:prstGeom prst="line">
@@ -9663,13 +9663,52 @@
       </p:sp>
       <p:sp>
         <p:nvSpPr>
-          <p:cNvPr id="13" name="Shape 10"/>
+          <p:cNvPr id="13" name="Text 10"/>
+          <p:cNvSpPr txBox="1"/>
+          <p:nvPr/>
+        </p:nvSpPr>
+        <p:spPr>
+          <a:xfrm>
+            <a:off x="10000244" y="1691640"/>
+            <a:ext cx="1642811" cy="237744"/>
+          </a:xfrm>
+          <a:prstGeom prst="rect">
+            <a:avLst/>
+          </a:prstGeom>
+          <a:noFill/>
+          <a:ln/>
+        </p:spPr>
+        <p:txBody>
+          <a:bodyPr wrap="square" lIns="0" tIns="0" rIns="0" bIns="0" rtlCol="0" anchor="t"/>
+          <a:lstStyle/>
+          <a:p>
+            <a:pPr algn="ctr" indent="0" marL="0">
+              <a:lnSpc>
+                <a:spcPct val="112000"/>
+              </a:lnSpc>
+              <a:buNone/>
+            </a:pPr>
+            <a:r>
+              <a:rPr lang="en-US" sz="1050" dirty="0">
+                <a:solidFill>
+                  <a:schemeClr val="accent3"/>
+                </a:solidFill>
+              </a:rPr>
+              <a:t>Ongoing</a:t>
+            </a:r>
+            <a:endParaRPr lang="en-US" sz="1050" dirty="0"/>
+          </a:p>
+        </p:txBody>
+      </p:sp>
+      <p:sp>
+        <p:nvSpPr>
+          <p:cNvPr id="14" name="Shape 11"/>
           <p:cNvSpPr/>
           <p:nvPr/>
         </p:nvSpPr>
         <p:spPr>
           <a:xfrm>
-            <a:off x="11643055" y="2020824"/>
+            <a:off x="10000244" y="2020824"/>
             <a:ext cx="0" cy="3739896"/>
           </a:xfrm>
           <a:prstGeom prst="line">
@@ -9686,7 +9725,30 @@
       </p:sp>
       <p:sp>
         <p:nvSpPr>
-          <p:cNvPr id="14" name="Shape 11"/>
+          <p:cNvPr id="15" name="Shape 12"/>
+          <p:cNvSpPr/>
+          <p:nvPr/>
+        </p:nvSpPr>
+        <p:spPr>
+          <a:xfrm>
+            <a:off x="11643055" y="2020824"/>
+            <a:ext cx="0" cy="3739896"/>
+          </a:xfrm>
+          <a:prstGeom prst="line">
+            <a:avLst/>
+          </a:prstGeom>
+          <a:noFill/>
+          <a:ln w="6350">
+            <a:solidFill>
+              <a:schemeClr val="accent5"/>
+            </a:solidFill>
+            <a:prstDash val="solid"/>
+          </a:ln>
+        </p:spPr>
+      </p:sp>
+      <p:sp>
+        <p:nvSpPr>
+          <p:cNvPr id="16" name="Shape 13"/>
           <p:cNvSpPr/>
           <p:nvPr/>
         </p:nvSpPr>
@@ -9709,14 +9771,14 @@
       </p:sp>
       <p:sp>
         <p:nvSpPr>
-          <p:cNvPr id="15" name="Text 12"/>
-          <p:cNvSpPr txBox="1"/>
-          <p:nvPr/>
-        </p:nvSpPr>
-        <p:spPr>
-          <a:xfrm>
-            <a:off x="548640" y="2267712"/>
-            <a:ext cx="411480" cy="292608"/>
+          <p:cNvPr id="17" name="Text 14"/>
+          <p:cNvSpPr txBox="1"/>
+          <p:nvPr/>
+        </p:nvSpPr>
+        <p:spPr>
+          <a:xfrm>
+            <a:off x="548640" y="2185416"/>
+            <a:ext cx="411480" cy="274320"/>
           </a:xfrm>
           <a:prstGeom prst="rect">
             <a:avLst/>
@@ -9751,14 +9813,14 @@
       </p:sp>
       <p:sp>
         <p:nvSpPr>
-          <p:cNvPr id="16" name="Text 13"/>
-          <p:cNvSpPr txBox="1"/>
-          <p:nvPr/>
-        </p:nvSpPr>
-        <p:spPr>
-          <a:xfrm>
-            <a:off x="960120" y="2249424"/>
-            <a:ext cx="2331720" cy="329184"/>
+          <p:cNvPr id="18" name="Text 15"/>
+          <p:cNvSpPr txBox="1"/>
+          <p:nvPr/>
+        </p:nvSpPr>
+        <p:spPr>
+          <a:xfrm>
+            <a:off x="960120" y="2148840"/>
+            <a:ext cx="2331720" cy="292608"/>
           </a:xfrm>
           <a:prstGeom prst="rect">
             <a:avLst/>
@@ -9793,14 +9855,53 @@
       </p:sp>
       <p:sp>
         <p:nvSpPr>
-          <p:cNvPr id="17" name="Shape 14"/>
+          <p:cNvPr id="19" name="Text 16"/>
+          <p:cNvSpPr txBox="1"/>
+          <p:nvPr/>
+        </p:nvSpPr>
+        <p:spPr>
+          <a:xfrm>
+            <a:off x="960120" y="2441448"/>
+            <a:ext cx="2286000" cy="237744"/>
+          </a:xfrm>
+          <a:prstGeom prst="rect">
+            <a:avLst/>
+          </a:prstGeom>
+          <a:noFill/>
+          <a:ln/>
+        </p:spPr>
+        <p:txBody>
+          <a:bodyPr wrap="square" lIns="0" tIns="0" rIns="0" bIns="0" rtlCol="0" anchor="t"/>
+          <a:lstStyle/>
+          <a:p>
+            <a:pPr algn="l" indent="0" marL="0">
+              <a:lnSpc>
+                <a:spcPct val="112000"/>
+              </a:lnSpc>
+              <a:buNone/>
+            </a:pPr>
+            <a:r>
+              <a:rPr lang="en-US" sz="1050" dirty="0">
+                <a:solidFill>
+                  <a:schemeClr val="accent2"/>
+                </a:solidFill>
+              </a:rPr>
+              <a:t>Domain · email · workspace · backup</a:t>
+            </a:r>
+            <a:endParaRPr lang="en-US" sz="1050" dirty="0"/>
+          </a:p>
+        </p:txBody>
+      </p:sp>
+      <p:sp>
+        <p:nvSpPr>
+          <p:cNvPr id="20" name="Shape 17"/>
           <p:cNvSpPr/>
           <p:nvPr/>
         </p:nvSpPr>
         <p:spPr>
           <a:xfrm>
-            <a:off x="3429000" y="2322576"/>
-            <a:ext cx="1263701" cy="219456"/>
+            <a:off x="3465576" y="2258568"/>
+            <a:ext cx="1569659" cy="274320"/>
           </a:xfrm>
           <a:prstGeom prst="rect">
             <a:avLst/>
@@ -9813,53 +9914,14 @@
       </p:sp>
       <p:sp>
         <p:nvSpPr>
-          <p:cNvPr id="18" name="Text 15"/>
-          <p:cNvSpPr txBox="1"/>
-          <p:nvPr/>
-        </p:nvSpPr>
-        <p:spPr>
-          <a:xfrm>
-            <a:off x="4820717" y="2249424"/>
-            <a:ext cx="6822338" cy="365760"/>
-          </a:xfrm>
-          <a:prstGeom prst="rect">
-            <a:avLst/>
-          </a:prstGeom>
-          <a:noFill/>
-          <a:ln/>
-        </p:spPr>
-        <p:txBody>
-          <a:bodyPr wrap="square" lIns="0" tIns="0" rIns="0" bIns="0" rtlCol="0" anchor="ctr"/>
-          <a:lstStyle/>
-          <a:p>
-            <a:pPr algn="l" indent="0" marL="0">
-              <a:lnSpc>
-                <a:spcPct val="112000"/>
-              </a:lnSpc>
-              <a:buNone/>
-            </a:pPr>
-            <a:r>
-              <a:rPr lang="en-US" sz="1150" dirty="0">
-                <a:solidFill>
-                  <a:schemeClr val="tx2"/>
-                </a:solidFill>
-              </a:rPr>
-              <a:t>Domain · email · workspace · backup</a:t>
-            </a:r>
-            <a:endParaRPr lang="en-US" sz="1150" dirty="0"/>
-          </a:p>
-        </p:txBody>
-      </p:sp>
-      <p:sp>
-        <p:nvSpPr>
-          <p:cNvPr id="19" name="Text 16"/>
-          <p:cNvSpPr txBox="1"/>
-          <p:nvPr/>
-        </p:nvSpPr>
-        <p:spPr>
-          <a:xfrm>
-            <a:off x="548640" y="2834640"/>
-            <a:ext cx="411480" cy="292608"/>
+          <p:cNvPr id="21" name="Text 18"/>
+          <p:cNvSpPr txBox="1"/>
+          <p:nvPr/>
+        </p:nvSpPr>
+        <p:spPr>
+          <a:xfrm>
+            <a:off x="548640" y="2788920"/>
+            <a:ext cx="411480" cy="274320"/>
           </a:xfrm>
           <a:prstGeom prst="rect">
             <a:avLst/>
@@ -9894,14 +9956,14 @@
       </p:sp>
       <p:sp>
         <p:nvSpPr>
-          <p:cNvPr id="20" name="Text 17"/>
-          <p:cNvSpPr txBox="1"/>
-          <p:nvPr/>
-        </p:nvSpPr>
-        <p:spPr>
-          <a:xfrm>
-            <a:off x="960120" y="2816352"/>
-            <a:ext cx="2331720" cy="329184"/>
+          <p:cNvPr id="22" name="Text 19"/>
+          <p:cNvSpPr txBox="1"/>
+          <p:nvPr/>
+        </p:nvSpPr>
+        <p:spPr>
+          <a:xfrm>
+            <a:off x="960120" y="2752344"/>
+            <a:ext cx="2331720" cy="292608"/>
           </a:xfrm>
           <a:prstGeom prst="rect">
             <a:avLst/>
@@ -9936,14 +9998,53 @@
       </p:sp>
       <p:sp>
         <p:nvSpPr>
-          <p:cNvPr id="21" name="Shape 18"/>
+          <p:cNvPr id="23" name="Text 20"/>
+          <p:cNvSpPr txBox="1"/>
+          <p:nvPr/>
+        </p:nvSpPr>
+        <p:spPr>
+          <a:xfrm>
+            <a:off x="960120" y="3044952"/>
+            <a:ext cx="2286000" cy="237744"/>
+          </a:xfrm>
+          <a:prstGeom prst="rect">
+            <a:avLst/>
+          </a:prstGeom>
+          <a:noFill/>
+          <a:ln/>
+        </p:spPr>
+        <p:txBody>
+          <a:bodyPr wrap="square" lIns="0" tIns="0" rIns="0" bIns="0" rtlCol="0" anchor="t"/>
+          <a:lstStyle/>
+          <a:p>
+            <a:pPr algn="l" indent="0" marL="0">
+              <a:lnSpc>
+                <a:spcPct val="112000"/>
+              </a:lnSpc>
+              <a:buNone/>
+            </a:pPr>
+            <a:r>
+              <a:rPr lang="en-US" sz="1050" dirty="0">
+                <a:solidFill>
+                  <a:schemeClr val="accent2"/>
+                </a:solidFill>
+              </a:rPr>
+              <a:t>Site live and connected to Google</a:t>
+            </a:r>
+            <a:endParaRPr lang="en-US" sz="1050" dirty="0"/>
+          </a:p>
+        </p:txBody>
+      </p:sp>
+      <p:sp>
+        <p:nvSpPr>
+          <p:cNvPr id="24" name="Shape 21"/>
           <p:cNvSpPr/>
           <p:nvPr/>
         </p:nvSpPr>
         <p:spPr>
           <a:xfrm>
-            <a:off x="4060850" y="2889504"/>
-            <a:ext cx="1895551" cy="219456"/>
+            <a:off x="4286982" y="2862072"/>
+            <a:ext cx="2391065" cy="274320"/>
           </a:xfrm>
           <a:prstGeom prst="rect">
             <a:avLst/>
@@ -9956,53 +10057,14 @@
       </p:sp>
       <p:sp>
         <p:nvSpPr>
-          <p:cNvPr id="22" name="Text 19"/>
-          <p:cNvSpPr txBox="1"/>
-          <p:nvPr/>
-        </p:nvSpPr>
-        <p:spPr>
-          <a:xfrm>
-            <a:off x="6084418" y="2816352"/>
-            <a:ext cx="5558638" cy="365760"/>
-          </a:xfrm>
-          <a:prstGeom prst="rect">
-            <a:avLst/>
-          </a:prstGeom>
-          <a:noFill/>
-          <a:ln/>
-        </p:spPr>
-        <p:txBody>
-          <a:bodyPr wrap="square" lIns="0" tIns="0" rIns="0" bIns="0" rtlCol="0" anchor="ctr"/>
-          <a:lstStyle/>
-          <a:p>
-            <a:pPr algn="l" indent="0" marL="0">
-              <a:lnSpc>
-                <a:spcPct val="112000"/>
-              </a:lnSpc>
-              <a:buNone/>
-            </a:pPr>
-            <a:r>
-              <a:rPr lang="en-US" sz="1150" dirty="0">
-                <a:solidFill>
-                  <a:schemeClr val="tx2"/>
-                </a:solidFill>
-              </a:rPr>
-              <a:t>Site live and connected to Google</a:t>
-            </a:r>
-            <a:endParaRPr lang="en-US" sz="1150" dirty="0"/>
-          </a:p>
-        </p:txBody>
-      </p:sp>
-      <p:sp>
-        <p:nvSpPr>
-          <p:cNvPr id="23" name="Text 20"/>
-          <p:cNvSpPr txBox="1"/>
-          <p:nvPr/>
-        </p:nvSpPr>
-        <p:spPr>
-          <a:xfrm>
-            <a:off x="548640" y="3401568"/>
-            <a:ext cx="411480" cy="292608"/>
+          <p:cNvPr id="25" name="Text 22"/>
+          <p:cNvSpPr txBox="1"/>
+          <p:nvPr/>
+        </p:nvSpPr>
+        <p:spPr>
+          <a:xfrm>
+            <a:off x="548640" y="3392424"/>
+            <a:ext cx="411480" cy="274320"/>
           </a:xfrm>
           <a:prstGeom prst="rect">
             <a:avLst/>
@@ -10037,14 +10099,14 @@
       </p:sp>
       <p:sp>
         <p:nvSpPr>
-          <p:cNvPr id="24" name="Text 21"/>
-          <p:cNvSpPr txBox="1"/>
-          <p:nvPr/>
-        </p:nvSpPr>
-        <p:spPr>
-          <a:xfrm>
-            <a:off x="960120" y="3383280"/>
-            <a:ext cx="2331720" cy="329184"/>
+          <p:cNvPr id="26" name="Text 23"/>
+          <p:cNvSpPr txBox="1"/>
+          <p:nvPr/>
+        </p:nvSpPr>
+        <p:spPr>
+          <a:xfrm>
+            <a:off x="960120" y="3355848"/>
+            <a:ext cx="2331720" cy="292608"/>
           </a:xfrm>
           <a:prstGeom prst="rect">
             <a:avLst/>
@@ -10079,14 +10141,53 @@
       </p:sp>
       <p:sp>
         <p:nvSpPr>
-          <p:cNvPr id="25" name="Shape 22"/>
+          <p:cNvPr id="27" name="Text 24"/>
+          <p:cNvSpPr txBox="1"/>
+          <p:nvPr/>
+        </p:nvSpPr>
+        <p:spPr>
+          <a:xfrm>
+            <a:off x="960120" y="3648456"/>
+            <a:ext cx="2286000" cy="237744"/>
+          </a:xfrm>
+          <a:prstGeom prst="rect">
+            <a:avLst/>
+          </a:prstGeom>
+          <a:noFill/>
+          <a:ln/>
+        </p:spPr>
+        <p:txBody>
+          <a:bodyPr wrap="square" lIns="0" tIns="0" rIns="0" bIns="0" rtlCol="0" anchor="t"/>
+          <a:lstStyle/>
+          <a:p>
+            <a:pPr algn="l" indent="0" marL="0">
+              <a:lnSpc>
+                <a:spcPct val="112000"/>
+              </a:lnSpc>
+              <a:buNone/>
+            </a:pPr>
+            <a:r>
+              <a:rPr lang="en-US" sz="1050" dirty="0">
+                <a:solidFill>
+                  <a:schemeClr val="accent2"/>
+                </a:solidFill>
+              </a:rPr>
+              <a:t>Verified Google Maps presence</a:t>
+            </a:r>
+            <a:endParaRPr lang="en-US" sz="1050" dirty="0"/>
+          </a:p>
+        </p:txBody>
+      </p:sp>
+      <p:sp>
+        <p:nvSpPr>
+          <p:cNvPr id="28" name="Shape 25"/>
           <p:cNvSpPr/>
           <p:nvPr/>
         </p:nvSpPr>
         <p:spPr>
           <a:xfrm>
-            <a:off x="4692701" y="3456432"/>
-            <a:ext cx="2527402" cy="219456"/>
+            <a:off x="5108387" y="3465576"/>
+            <a:ext cx="4855281" cy="274320"/>
           </a:xfrm>
           <a:prstGeom prst="rect">
             <a:avLst/>
@@ -10099,53 +10200,14 @@
       </p:sp>
       <p:sp>
         <p:nvSpPr>
-          <p:cNvPr id="26" name="Text 23"/>
-          <p:cNvSpPr txBox="1"/>
-          <p:nvPr/>
-        </p:nvSpPr>
-        <p:spPr>
-          <a:xfrm>
-            <a:off x="7348118" y="3383280"/>
-            <a:ext cx="4294937" cy="365760"/>
-          </a:xfrm>
-          <a:prstGeom prst="rect">
-            <a:avLst/>
-          </a:prstGeom>
-          <a:noFill/>
-          <a:ln/>
-        </p:spPr>
-        <p:txBody>
-          <a:bodyPr wrap="square" lIns="0" tIns="0" rIns="0" bIns="0" rtlCol="0" anchor="ctr"/>
-          <a:lstStyle/>
-          <a:p>
-            <a:pPr algn="l" indent="0" marL="0">
-              <a:lnSpc>
-                <a:spcPct val="112000"/>
-              </a:lnSpc>
-              <a:buNone/>
-            </a:pPr>
-            <a:r>
-              <a:rPr lang="en-US" sz="1150" dirty="0">
-                <a:solidFill>
-                  <a:schemeClr val="tx2"/>
-                </a:solidFill>
-              </a:rPr>
-              <a:t>Verified Google Maps presence</a:t>
-            </a:r>
-            <a:endParaRPr lang="en-US" sz="1150" dirty="0"/>
-          </a:p>
-        </p:txBody>
-      </p:sp>
-      <p:sp>
-        <p:nvSpPr>
-          <p:cNvPr id="27" name="Text 24"/>
-          <p:cNvSpPr txBox="1"/>
-          <p:nvPr/>
-        </p:nvSpPr>
-        <p:spPr>
-          <a:xfrm>
-            <a:off x="548640" y="3968496"/>
-            <a:ext cx="411480" cy="292608"/>
+          <p:cNvPr id="29" name="Text 26"/>
+          <p:cNvSpPr txBox="1"/>
+          <p:nvPr/>
+        </p:nvSpPr>
+        <p:spPr>
+          <a:xfrm>
+            <a:off x="548640" y="3995928"/>
+            <a:ext cx="411480" cy="274320"/>
           </a:xfrm>
           <a:prstGeom prst="rect">
             <a:avLst/>
@@ -10180,14 +10242,14 @@
       </p:sp>
       <p:sp>
         <p:nvSpPr>
-          <p:cNvPr id="28" name="Text 25"/>
-          <p:cNvSpPr txBox="1"/>
-          <p:nvPr/>
-        </p:nvSpPr>
-        <p:spPr>
-          <a:xfrm>
-            <a:off x="960120" y="3950208"/>
-            <a:ext cx="2331720" cy="329184"/>
+          <p:cNvPr id="30" name="Text 27"/>
+          <p:cNvSpPr txBox="1"/>
+          <p:nvPr/>
+        </p:nvSpPr>
+        <p:spPr>
+          <a:xfrm>
+            <a:off x="960120" y="3959352"/>
+            <a:ext cx="2331720" cy="292608"/>
           </a:xfrm>
           <a:prstGeom prst="rect">
             <a:avLst/>
@@ -10222,14 +10284,53 @@
       </p:sp>
       <p:sp>
         <p:nvSpPr>
-          <p:cNvPr id="29" name="Shape 26"/>
+          <p:cNvPr id="31" name="Text 28"/>
+          <p:cNvSpPr txBox="1"/>
+          <p:nvPr/>
+        </p:nvSpPr>
+        <p:spPr>
+          <a:xfrm>
+            <a:off x="960120" y="4251960"/>
+            <a:ext cx="2286000" cy="237744"/>
+          </a:xfrm>
+          <a:prstGeom prst="rect">
+            <a:avLst/>
+          </a:prstGeom>
+          <a:noFill/>
+          <a:ln/>
+        </p:spPr>
+        <p:txBody>
+          <a:bodyPr wrap="square" lIns="0" tIns="0" rIns="0" bIns="0" rtlCol="0" anchor="t"/>
+          <a:lstStyle/>
+          <a:p>
+            <a:pPr algn="l" indent="0" marL="0">
+              <a:lnSpc>
+                <a:spcPct val="112000"/>
+              </a:lnSpc>
+              <a:buNone/>
+            </a:pPr>
+            <a:r>
+              <a:rPr lang="en-US" sz="1050" dirty="0">
+                <a:solidFill>
+                  <a:schemeClr val="accent2"/>
+                </a:solidFill>
+              </a:rPr>
+              <a:t>Projects and services discoverable</a:t>
+            </a:r>
+            <a:endParaRPr lang="en-US" sz="1050" dirty="0"/>
+          </a:p>
+        </p:txBody>
+      </p:sp>
+      <p:sp>
+        <p:nvSpPr>
+          <p:cNvPr id="32" name="Shape 29"/>
           <p:cNvSpPr/>
           <p:nvPr/>
         </p:nvSpPr>
         <p:spPr>
           <a:xfrm>
-            <a:off x="5324551" y="4023360"/>
-            <a:ext cx="4422953" cy="219456"/>
+            <a:off x="5929793" y="4069080"/>
+            <a:ext cx="4033876" cy="274320"/>
           </a:xfrm>
           <a:prstGeom prst="rect">
             <a:avLst/>
@@ -10242,53 +10343,14 @@
       </p:sp>
       <p:sp>
         <p:nvSpPr>
-          <p:cNvPr id="30" name="Text 27"/>
-          <p:cNvSpPr txBox="1"/>
-          <p:nvPr/>
-        </p:nvSpPr>
-        <p:spPr>
-          <a:xfrm>
-            <a:off x="9875520" y="3950208"/>
-            <a:ext cx="1767535" cy="365760"/>
-          </a:xfrm>
-          <a:prstGeom prst="rect">
-            <a:avLst/>
-          </a:prstGeom>
-          <a:noFill/>
-          <a:ln/>
-        </p:spPr>
-        <p:txBody>
-          <a:bodyPr wrap="square" lIns="0" tIns="0" rIns="0" bIns="0" rtlCol="0" anchor="ctr"/>
-          <a:lstStyle/>
-          <a:p>
-            <a:pPr algn="l" indent="0" marL="0">
-              <a:lnSpc>
-                <a:spcPct val="112000"/>
-              </a:lnSpc>
-              <a:buNone/>
-            </a:pPr>
-            <a:r>
-              <a:rPr lang="en-US" sz="1150" dirty="0">
-                <a:solidFill>
-                  <a:schemeClr val="tx2"/>
-                </a:solidFill>
-              </a:rPr>
-              <a:t>Projects and services discoverable</a:t>
-            </a:r>
-            <a:endParaRPr lang="en-US" sz="1150" dirty="0"/>
-          </a:p>
-        </p:txBody>
-      </p:sp>
-      <p:sp>
-        <p:nvSpPr>
-          <p:cNvPr id="31" name="Text 28"/>
-          <p:cNvSpPr txBox="1"/>
-          <p:nvPr/>
-        </p:nvSpPr>
-        <p:spPr>
-          <a:xfrm>
-            <a:off x="548640" y="4535424"/>
-            <a:ext cx="411480" cy="292608"/>
+          <p:cNvPr id="33" name="Text 30"/>
+          <p:cNvSpPr txBox="1"/>
+          <p:nvPr/>
+        </p:nvSpPr>
+        <p:spPr>
+          <a:xfrm>
+            <a:off x="548640" y="4599432"/>
+            <a:ext cx="411480" cy="274320"/>
           </a:xfrm>
           <a:prstGeom prst="rect">
             <a:avLst/>
@@ -10323,14 +10385,14 @@
       </p:sp>
       <p:sp>
         <p:nvSpPr>
-          <p:cNvPr id="32" name="Text 29"/>
-          <p:cNvSpPr txBox="1"/>
-          <p:nvPr/>
-        </p:nvSpPr>
-        <p:spPr>
-          <a:xfrm>
-            <a:off x="960120" y="4517136"/>
-            <a:ext cx="2331720" cy="329184"/>
+          <p:cNvPr id="34" name="Text 31"/>
+          <p:cNvSpPr txBox="1"/>
+          <p:nvPr/>
+        </p:nvSpPr>
+        <p:spPr>
+          <a:xfrm>
+            <a:off x="960120" y="4562856"/>
+            <a:ext cx="2331720" cy="292608"/>
           </a:xfrm>
           <a:prstGeom prst="rect">
             <a:avLst/>
@@ -10357,7 +10419,7 @@
                 <a:ea typeface="+mj-lt" pitchFamily="34" charset="-122"/>
                 <a:cs typeface="+mj-lt" pitchFamily="34" charset="-120"/>
               </a:rPr>
-              <a:t>Authority &amp; digital growth</a:t>
+              <a:t>Authority &amp; growth</a:t>
             </a:r>
             <a:endParaRPr lang="en-US" sz="1500" dirty="0"/>
           </a:p>
@@ -10365,14 +10427,53 @@
       </p:sp>
       <p:sp>
         <p:nvSpPr>
-          <p:cNvPr id="33" name="Shape 30"/>
+          <p:cNvPr id="35" name="Text 32"/>
+          <p:cNvSpPr txBox="1"/>
+          <p:nvPr/>
+        </p:nvSpPr>
+        <p:spPr>
+          <a:xfrm>
+            <a:off x="960120" y="4855464"/>
+            <a:ext cx="2286000" cy="237744"/>
+          </a:xfrm>
+          <a:prstGeom prst="rect">
+            <a:avLst/>
+          </a:prstGeom>
+          <a:noFill/>
+          <a:ln/>
+        </p:spPr>
+        <p:txBody>
+          <a:bodyPr wrap="square" lIns="0" tIns="0" rIns="0" bIns="0" rtlCol="0" anchor="t"/>
+          <a:lstStyle/>
+          <a:p>
+            <a:pPr algn="l" indent="0" marL="0">
+              <a:lnSpc>
+                <a:spcPct val="112000"/>
+              </a:lnSpc>
+              <a:buNone/>
+            </a:pPr>
+            <a:r>
+              <a:rPr lang="en-US" sz="1050" dirty="0">
+                <a:solidFill>
+                  <a:schemeClr val="accent2"/>
+                </a:solidFill>
+              </a:rPr>
+              <a:t>Platforms · publications · reviews</a:t>
+            </a:r>
+            <a:endParaRPr lang="en-US" sz="1050" dirty="0"/>
+          </a:p>
+        </p:txBody>
+      </p:sp>
+      <p:sp>
+        <p:nvSpPr>
+          <p:cNvPr id="36" name="Shape 33"/>
           <p:cNvSpPr/>
           <p:nvPr/>
         </p:nvSpPr>
         <p:spPr>
           <a:xfrm>
-            <a:off x="8483803" y="4590288"/>
-            <a:ext cx="2527402" cy="219456"/>
+            <a:off x="8394009" y="4672584"/>
+            <a:ext cx="1569659" cy="274320"/>
           </a:xfrm>
           <a:prstGeom prst="rect">
             <a:avLst/>
@@ -10385,14 +10486,14 @@
       </p:sp>
       <p:sp>
         <p:nvSpPr>
-          <p:cNvPr id="34" name="Shape 31"/>
+          <p:cNvPr id="37" name="Shape 34"/>
           <p:cNvSpPr/>
           <p:nvPr/>
         </p:nvSpPr>
         <p:spPr>
           <a:xfrm>
-            <a:off x="11011205" y="4590288"/>
-            <a:ext cx="631850" cy="219456"/>
+            <a:off x="10036820" y="4672584"/>
+            <a:ext cx="1569659" cy="274320"/>
           </a:xfrm>
           <a:prstGeom prst="rect">
             <a:avLst/>
@@ -10407,53 +10508,14 @@
       </p:sp>
       <p:sp>
         <p:nvSpPr>
-          <p:cNvPr id="35" name="Text 32"/>
-          <p:cNvSpPr txBox="1"/>
-          <p:nvPr/>
-        </p:nvSpPr>
-        <p:spPr>
-          <a:xfrm>
-            <a:off x="3429000" y="4517136"/>
-            <a:ext cx="4926787" cy="365760"/>
-          </a:xfrm>
-          <a:prstGeom prst="rect">
-            <a:avLst/>
-          </a:prstGeom>
-          <a:noFill/>
-          <a:ln/>
-        </p:spPr>
-        <p:txBody>
-          <a:bodyPr wrap="square" lIns="0" tIns="0" rIns="0" bIns="0" rtlCol="0" anchor="ctr"/>
-          <a:lstStyle/>
-          <a:p>
-            <a:pPr algn="r" indent="0" marL="0">
-              <a:lnSpc>
-                <a:spcPct val="112000"/>
-              </a:lnSpc>
-              <a:buNone/>
-            </a:pPr>
-            <a:r>
-              <a:rPr lang="en-US" sz="1150" dirty="0">
-                <a:solidFill>
-                  <a:schemeClr val="tx2"/>
-                </a:solidFill>
-              </a:rPr>
-              <a:t>Platforms · publications · reviews</a:t>
-            </a:r>
-            <a:endParaRPr lang="en-US" sz="1150" dirty="0"/>
-          </a:p>
-        </p:txBody>
-      </p:sp>
-      <p:sp>
-        <p:nvSpPr>
-          <p:cNvPr id="36" name="Text 33"/>
-          <p:cNvSpPr txBox="1"/>
-          <p:nvPr/>
-        </p:nvSpPr>
-        <p:spPr>
-          <a:xfrm>
-            <a:off x="548640" y="5102352"/>
-            <a:ext cx="411480" cy="292608"/>
+          <p:cNvPr id="38" name="Text 35"/>
+          <p:cNvSpPr txBox="1"/>
+          <p:nvPr/>
+        </p:nvSpPr>
+        <p:spPr>
+          <a:xfrm>
+            <a:off x="548640" y="5202936"/>
+            <a:ext cx="411480" cy="274320"/>
           </a:xfrm>
           <a:prstGeom prst="rect">
             <a:avLst/>
@@ -10488,14 +10550,14 @@
       </p:sp>
       <p:sp>
         <p:nvSpPr>
-          <p:cNvPr id="37" name="Text 34"/>
-          <p:cNvSpPr txBox="1"/>
-          <p:nvPr/>
-        </p:nvSpPr>
-        <p:spPr>
-          <a:xfrm>
-            <a:off x="960120" y="5084064"/>
-            <a:ext cx="2331720" cy="329184"/>
+          <p:cNvPr id="39" name="Text 36"/>
+          <p:cNvSpPr txBox="1"/>
+          <p:nvPr/>
+        </p:nvSpPr>
+        <p:spPr>
+          <a:xfrm>
+            <a:off x="960120" y="5166360"/>
+            <a:ext cx="2331720" cy="292608"/>
           </a:xfrm>
           <a:prstGeom prst="rect">
             <a:avLst/>
@@ -10530,14 +10592,53 @@
       </p:sp>
       <p:sp>
         <p:nvSpPr>
-          <p:cNvPr id="38" name="Shape 35"/>
+          <p:cNvPr id="40" name="Text 37"/>
+          <p:cNvSpPr txBox="1"/>
+          <p:nvPr/>
+        </p:nvSpPr>
+        <p:spPr>
+          <a:xfrm>
+            <a:off x="960120" y="5458968"/>
+            <a:ext cx="2286000" cy="237744"/>
+          </a:xfrm>
+          <a:prstGeom prst="rect">
+            <a:avLst/>
+          </a:prstGeom>
+          <a:noFill/>
+          <a:ln/>
+        </p:spPr>
+        <p:txBody>
+          <a:bodyPr wrap="square" lIns="0" tIns="0" rIns="0" bIns="0" rtlCol="0" anchor="t"/>
+          <a:lstStyle/>
+          <a:p>
+            <a:pPr algn="l" indent="0" marL="0">
+              <a:lnSpc>
+                <a:spcPct val="112000"/>
+              </a:lnSpc>
+              <a:buNone/>
+            </a:pPr>
+            <a:r>
+              <a:rPr lang="en-US" sz="1050" dirty="0">
+                <a:solidFill>
+                  <a:schemeClr val="accent2"/>
+                </a:solidFill>
+              </a:rPr>
+              <a:t>Dashboard · monthly report</a:t>
+            </a:r>
+            <a:endParaRPr lang="en-US" sz="1050" dirty="0"/>
+          </a:p>
+        </p:txBody>
+      </p:sp>
+      <p:sp>
+        <p:nvSpPr>
+          <p:cNvPr id="41" name="Shape 38"/>
           <p:cNvSpPr/>
           <p:nvPr/>
         </p:nvSpPr>
         <p:spPr>
           <a:xfrm>
-            <a:off x="6588252" y="5157216"/>
-            <a:ext cx="631850" cy="219456"/>
+            <a:off x="8394009" y="5276088"/>
+            <a:ext cx="1569659" cy="274320"/>
           </a:xfrm>
           <a:prstGeom prst="rect">
             <a:avLst/>
@@ -10550,14 +10651,14 @@
       </p:sp>
       <p:sp>
         <p:nvSpPr>
-          <p:cNvPr id="39" name="Shape 36"/>
+          <p:cNvPr id="42" name="Shape 39"/>
           <p:cNvSpPr/>
           <p:nvPr/>
         </p:nvSpPr>
         <p:spPr>
           <a:xfrm>
-            <a:off x="7220102" y="5157216"/>
-            <a:ext cx="4422953" cy="219456"/>
+            <a:off x="10036820" y="5276088"/>
+            <a:ext cx="1569659" cy="274320"/>
           </a:xfrm>
           <a:prstGeom prst="rect">
             <a:avLst/>
@@ -10572,46 +10673,7 @@
       </p:sp>
       <p:sp>
         <p:nvSpPr>
-          <p:cNvPr id="40" name="Text 37"/>
-          <p:cNvSpPr txBox="1"/>
-          <p:nvPr/>
-        </p:nvSpPr>
-        <p:spPr>
-          <a:xfrm>
-            <a:off x="3429000" y="5084064"/>
-            <a:ext cx="3031236" cy="365760"/>
-          </a:xfrm>
-          <a:prstGeom prst="rect">
-            <a:avLst/>
-          </a:prstGeom>
-          <a:noFill/>
-          <a:ln/>
-        </p:spPr>
-        <p:txBody>
-          <a:bodyPr wrap="square" lIns="0" tIns="0" rIns="0" bIns="0" rtlCol="0" anchor="ctr"/>
-          <a:lstStyle/>
-          <a:p>
-            <a:pPr algn="r" indent="0" marL="0">
-              <a:lnSpc>
-                <a:spcPct val="112000"/>
-              </a:lnSpc>
-              <a:buNone/>
-            </a:pPr>
-            <a:r>
-              <a:rPr lang="en-US" sz="1150" dirty="0">
-                <a:solidFill>
-                  <a:schemeClr val="tx2"/>
-                </a:solidFill>
-              </a:rPr>
-              <a:t>Dashboard · monthly report</a:t>
-            </a:r>
-            <a:endParaRPr lang="en-US" sz="1150" dirty="0"/>
-          </a:p>
-        </p:txBody>
-      </p:sp>
-      <p:sp>
-        <p:nvSpPr>
-          <p:cNvPr id="41" name="Shape 38"/>
+          <p:cNvPr id="43" name="Shape 40"/>
           <p:cNvSpPr/>
           <p:nvPr/>
         </p:nvSpPr>
@@ -10634,7 +10696,7 @@
       </p:sp>
       <p:sp>
         <p:nvSpPr>
-          <p:cNvPr id="42" name="Text 39"/>
+          <p:cNvPr id="44" name="Text 41"/>
           <p:cNvSpPr txBox="1"/>
           <p:nvPr/>
         </p:nvSpPr>
@@ -10707,7 +10769,7 @@
                   <a:schemeClr val="accent2"/>
                 </a:solidFill>
               </a:rPr>
-              <a:t> — ongoing, every month    ·    Begins after alignment and access</a:t>
+              <a:t> — every month    ·    Begins after alignment and access</a:t>
             </a:r>
             <a:endParaRPr lang="en-US" sz="1100" dirty="0"/>
           </a:p>

</xml_diff>